<commit_message>
move calc_macro_ar_impact to utils.R
</commit_message>
<xml_diff>
--- a/03_burden_calculations.pptx
+++ b/03_burden_calculations.pptx
@@ -16,7 +16,6 @@
     <p:sldId id="264" r:id="rId10"/>
     <p:sldId id="265" r:id="rId11"/>
     <p:sldId id="266" r:id="rId12"/>
-    <p:sldId id="267" r:id="rId13"/>
   </p:sldIdLst>
   <p:sldSz cx="9144000" cy="5143500" type="screen16x9"/>
   <p:notesSz cx="6858000" cy="9144000"/>
@@ -3183,115 +3182,6 @@
           <a:chExt cx="0" cy="0"/>
         </a:xfrm>
       </p:grpSpPr>
-      <p:sp>
-        <p:nvSpPr>
-          <p:cNvPr id="2" name="Title 1"/>
-          <p:cNvSpPr>
-            <a:spLocks noGrp="1"/>
-          </p:cNvSpPr>
-          <p:nvPr>
-            <p:ph type="title"/>
-          </p:nvPr>
-        </p:nvSpPr>
-        <p:spPr/>
-        <p:txBody>
-          <a:bodyPr/>
-          <a:lstStyle/>
-          <a:p>
-            <a:pPr lvl="0" indent="0" marL="0">
-              <a:buNone/>
-            </a:pPr>
-            <a:r>
-              <a:rPr/>
-              <a:t>Gesundheitsauswirkungen in Regionen</a:t>
-            </a:r>
-          </a:p>
-        </p:txBody>
-      </p:sp>
-      <p:pic>
-        <p:nvPicPr>
-          <p:cNvPr descr="03_burden_calculations_files/figure-pptx/fig-ballubgsraeume-1.png" id="0" name="Picture 1"/>
-          <p:cNvPicPr>
-            <a:picLocks noGrp="1" noChangeAspect="1"/>
-          </p:cNvPicPr>
-          <p:nvPr/>
-        </p:nvPicPr>
-        <p:blipFill>
-          <a:blip r:embed="rId2"/>
-          <a:stretch>
-            <a:fillRect/>
-          </a:stretch>
-        </p:blipFill>
-        <p:spPr bwMode="auto">
-          <a:xfrm>
-            <a:off x="1689100" y="1193800"/>
-            <a:ext cx="5765800" cy="2882900"/>
-          </a:xfrm>
-          <a:prstGeom prst="rect">
-            <a:avLst/>
-          </a:prstGeom>
-          <a:noFill/>
-          <a:ln w="9525">
-            <a:noFill/>
-            <a:headEnd/>
-            <a:tailEnd/>
-          </a:ln>
-        </p:spPr>
-      </p:pic>
-      <p:sp>
-        <p:nvSpPr>
-          <p:cNvPr id="1" name="TextBox 3"/>
-          <p:cNvSpPr txBox="1"/>
-          <p:nvPr>
-            <p:ph idx="1"/>
-          </p:nvPr>
-        </p:nvSpPr>
-        <p:spPr>
-          <a:xfrm>
-            <a:off x="457200" y="4076700"/>
-            <a:ext cx="8229600" cy="508000"/>
-          </a:xfrm>
-          <a:prstGeom prst="rect">
-            <a:avLst/>
-          </a:prstGeom>
-          <a:noFill/>
-        </p:spPr>
-        <p:txBody>
-          <a:bodyPr/>
-          <a:lstStyle/>
-          <a:p>
-            <a:pPr lvl="0" indent="0" marL="0" algn="ctr">
-              <a:buNone/>
-            </a:pPr>
-            <a:r>
-              <a:rPr/>
-              <a:t>Figure 2</a:t>
-            </a:r>
-          </a:p>
-        </p:txBody>
-      </p:sp>
-    </p:spTree>
-  </p:cSld>
-</p:sld>
-</file>
-
-<file path=ppt/slides/slide11.xml><?xml version="1.0" encoding="utf-8"?>
-<p:sld xmlns:a="http://schemas.openxmlformats.org/drawingml/2006/main" xmlns:r="http://schemas.openxmlformats.org/officeDocument/2006/relationships" xmlns:p="http://schemas.openxmlformats.org/presentationml/2006/main">
-  <p:cSld>
-    <p:spTree>
-      <p:nvGrpSpPr>
-        <p:cNvPr id="1" name=""/>
-        <p:cNvGrpSpPr/>
-        <p:nvPr/>
-      </p:nvGrpSpPr>
-      <p:grpSpPr>
-        <a:xfrm>
-          <a:off x="0" y="0"/>
-          <a:ext cx="0" cy="0"/>
-          <a:chOff x="0" y="0"/>
-          <a:chExt cx="0" cy="0"/>
-        </a:xfrm>
-      </p:grpSpPr>
       <p:pic>
         <p:nvPicPr>
           <p:cNvPr descr="03_burden_calculations_files/figure-pptx/plotKAGZRM_burden-1.png" id="0" name="Picture 1"/>
@@ -3327,7 +3217,7 @@
 </p:sld>
 </file>
 
-<file path=ppt/slides/slide12.xml><?xml version="1.0" encoding="utf-8"?>
+<file path=ppt/slides/slide11.xml><?xml version="1.0" encoding="utf-8"?>
 <p:sld xmlns:a="http://schemas.openxmlformats.org/drawingml/2006/main" xmlns:r="http://schemas.openxmlformats.org/officeDocument/2006/relationships" xmlns:p="http://schemas.openxmlformats.org/presentationml/2006/main">
   <p:cSld>
     <p:spTree>
@@ -3700,78 +3590,6 @@
             <p:ph type="title"/>
           </p:nvPr>
         </p:nvSpPr>
-        <p:spPr/>
-        <p:txBody>
-          <a:bodyPr/>
-          <a:lstStyle/>
-          <a:p>
-            <a:pPr lvl="0" indent="0" marL="0">
-              <a:buNone/>
-            </a:pPr>
-            <a:r>
-              <a:rPr/>
-              <a:t>Gesundheitsauswirkungen berechnen</a:t>
-            </a:r>
-          </a:p>
-        </p:txBody>
-      </p:sp>
-      <p:sp>
-        <p:nvSpPr>
-          <p:cNvPr id="3" name="Content Placeholder 2"/>
-          <p:cNvSpPr>
-            <a:spLocks noGrp="1"/>
-          </p:cNvSpPr>
-          <p:nvPr>
-            <p:ph idx="1"/>
-          </p:nvPr>
-        </p:nvSpPr>
-        <p:spPr/>
-        <p:txBody>
-          <a:bodyPr/>
-          <a:lstStyle/>
-          <a:p>
-            <a:pPr lvl="0" indent="0" marL="0">
-              <a:buNone/>
-            </a:pPr>
-            <a:r>
-              <a:rPr/>
-              <a:t>Funktion zur Berechnung der Gesundheitsauswirkungen</a:t>
-            </a:r>
-          </a:p>
-        </p:txBody>
-      </p:sp>
-    </p:spTree>
-  </p:cSld>
-</p:sld>
-</file>
-
-<file path=ppt/slides/slide6.xml><?xml version="1.0" encoding="utf-8"?>
-<p:sld xmlns:a="http://schemas.openxmlformats.org/drawingml/2006/main" xmlns:r="http://schemas.openxmlformats.org/officeDocument/2006/relationships" xmlns:p="http://schemas.openxmlformats.org/presentationml/2006/main">
-  <p:cSld>
-    <p:spTree>
-      <p:nvGrpSpPr>
-        <p:cNvPr id="1" name=""/>
-        <p:cNvGrpSpPr/>
-        <p:nvPr/>
-      </p:nvGrpSpPr>
-      <p:grpSpPr>
-        <a:xfrm>
-          <a:off x="0" y="0"/>
-          <a:ext cx="0" cy="0"/>
-          <a:chOff x="0" y="0"/>
-          <a:chExt cx="0" cy="0"/>
-        </a:xfrm>
-      </p:grpSpPr>
-      <p:sp>
-        <p:nvSpPr>
-          <p:cNvPr id="2" name="Title 1"/>
-          <p:cNvSpPr>
-            <a:spLocks noGrp="1"/>
-          </p:cNvSpPr>
-          <p:nvPr>
-            <p:ph type="title"/>
-          </p:nvPr>
-        </p:nvSpPr>
         <p:spPr>
           <a:xfrm>
             <a:off x="457201" y="204787"/>
@@ -11896,7 +11714,7 @@
 </p:sld>
 </file>
 
-<file path=ppt/slides/slide7.xml><?xml version="1.0" encoding="utf-8"?>
+<file path=ppt/slides/slide6.xml><?xml version="1.0" encoding="utf-8"?>
 <p:sld xmlns:a="http://schemas.openxmlformats.org/drawingml/2006/main" xmlns:r="http://schemas.openxmlformats.org/officeDocument/2006/relationships" xmlns:p="http://schemas.openxmlformats.org/presentationml/2006/main">
   <p:cSld>
     <p:spTree>
@@ -20038,7 +19856,7 @@
 </p:sld>
 </file>
 
-<file path=ppt/slides/slide8.xml><?xml version="1.0" encoding="utf-8"?>
+<file path=ppt/slides/slide7.xml><?xml version="1.0" encoding="utf-8"?>
 <p:sld xmlns:a="http://schemas.openxmlformats.org/drawingml/2006/main" xmlns:r="http://schemas.openxmlformats.org/officeDocument/2006/relationships" xmlns:p="http://schemas.openxmlformats.org/presentationml/2006/main">
   <p:cSld>
     <p:spTree>
@@ -20390,7 +20208,7 @@
 </p:sld>
 </file>
 
-<file path=ppt/slides/slide9.xml><?xml version="1.0" encoding="utf-8"?>
+<file path=ppt/slides/slide8.xml><?xml version="1.0" encoding="utf-8"?>
 <p:sld xmlns:a="http://schemas.openxmlformats.org/drawingml/2006/main" xmlns:r="http://schemas.openxmlformats.org/officeDocument/2006/relationships" xmlns:p="http://schemas.openxmlformats.org/presentationml/2006/main">
   <p:cSld>
     <p:spTree>
@@ -20492,6 +20310,115 @@
           </a:ln>
         </p:spPr>
       </p:pic>
+    </p:spTree>
+  </p:cSld>
+</p:sld>
+</file>
+
+<file path=ppt/slides/slide9.xml><?xml version="1.0" encoding="utf-8"?>
+<p:sld xmlns:a="http://schemas.openxmlformats.org/drawingml/2006/main" xmlns:r="http://schemas.openxmlformats.org/officeDocument/2006/relationships" xmlns:p="http://schemas.openxmlformats.org/presentationml/2006/main">
+  <p:cSld>
+    <p:spTree>
+      <p:nvGrpSpPr>
+        <p:cNvPr id="1" name=""/>
+        <p:cNvGrpSpPr/>
+        <p:nvPr/>
+      </p:nvGrpSpPr>
+      <p:grpSpPr>
+        <a:xfrm>
+          <a:off x="0" y="0"/>
+          <a:ext cx="0" cy="0"/>
+          <a:chOff x="0" y="0"/>
+          <a:chExt cx="0" cy="0"/>
+        </a:xfrm>
+      </p:grpSpPr>
+      <p:sp>
+        <p:nvSpPr>
+          <p:cNvPr id="2" name="Title 1"/>
+          <p:cNvSpPr>
+            <a:spLocks noGrp="1"/>
+          </p:cNvSpPr>
+          <p:nvPr>
+            <p:ph type="title"/>
+          </p:nvPr>
+        </p:nvSpPr>
+        <p:spPr/>
+        <p:txBody>
+          <a:bodyPr/>
+          <a:lstStyle/>
+          <a:p>
+            <a:pPr lvl="0" indent="0" marL="0">
+              <a:buNone/>
+            </a:pPr>
+            <a:r>
+              <a:rPr/>
+              <a:t>Gesundheitsauswirkungen in Regionen</a:t>
+            </a:r>
+          </a:p>
+        </p:txBody>
+      </p:sp>
+      <p:pic>
+        <p:nvPicPr>
+          <p:cNvPr descr="03_burden_calculations_files/figure-pptx/fig-ballubgsraeume-1.png" id="0" name="Picture 1"/>
+          <p:cNvPicPr>
+            <a:picLocks noGrp="1" noChangeAspect="1"/>
+          </p:cNvPicPr>
+          <p:nvPr/>
+        </p:nvPicPr>
+        <p:blipFill>
+          <a:blip r:embed="rId2"/>
+          <a:stretch>
+            <a:fillRect/>
+          </a:stretch>
+        </p:blipFill>
+        <p:spPr bwMode="auto">
+          <a:xfrm>
+            <a:off x="1689100" y="1193800"/>
+            <a:ext cx="5765800" cy="2882900"/>
+          </a:xfrm>
+          <a:prstGeom prst="rect">
+            <a:avLst/>
+          </a:prstGeom>
+          <a:noFill/>
+          <a:ln w="9525">
+            <a:noFill/>
+            <a:headEnd/>
+            <a:tailEnd/>
+          </a:ln>
+        </p:spPr>
+      </p:pic>
+      <p:sp>
+        <p:nvSpPr>
+          <p:cNvPr id="1" name="TextBox 3"/>
+          <p:cNvSpPr txBox="1"/>
+          <p:nvPr>
+            <p:ph idx="1"/>
+          </p:nvPr>
+        </p:nvSpPr>
+        <p:spPr>
+          <a:xfrm>
+            <a:off x="457200" y="4076700"/>
+            <a:ext cx="8229600" cy="508000"/>
+          </a:xfrm>
+          <a:prstGeom prst="rect">
+            <a:avLst/>
+          </a:prstGeom>
+          <a:noFill/>
+        </p:spPr>
+        <p:txBody>
+          <a:bodyPr/>
+          <a:lstStyle/>
+          <a:p>
+            <a:pPr lvl="0" indent="0" marL="0" algn="ctr">
+              <a:buNone/>
+            </a:pPr>
+            <a:r>
+              <a:rPr/>
+              <a:t>Figure 2</a:t>
+            </a:r>
+          </a:p>
+        </p:txBody>
+      </p:sp>
     </p:spTree>
   </p:cSld>
 </p:sld>

</xml_diff>